<commit_message>
docs: add team member names to presentations and readme
</commit_message>
<xml_diff>
--- a/docs/Kompetent-Buergerassistent-2030.pptx
+++ b/docs/Kompetent-Buergerassistent-2030.pptx
@@ -512,7 +512,7 @@
           <a:lstStyle/>
           <a:p>
             <a:r>
-              <a:t>Intro: Begrüßung der Jury. Kompetent ist der Prototyp für Österreichs universellen KI-Bürgerassistenten für 2030. Er löst das Problem von 10+ fragmentierten Portalen und unverständlicher Behördensprache durch empathische, rechtssichere Dialoge.</a:t>
+              <a:t>Intro: Begrüßung der Jury durch das Team (Goi Garg, Cajetan Perwein, Jeet Gupta, Reyan Zein). Kompetent ist der Prototyp für Österreichs universellen KI-Bürgerassistenten für 2030.</a:t>
             </a:r>
           </a:p>
         </p:txBody>
@@ -652,7 +652,7 @@
           <a:lstStyle/>
           <a:p>
             <a:r>
-              <a:t>Abschluss und Einladung zum Live-Test. Fragen der Jury beantworten.</a:t>
+              <a:t>Abschluss und Einladung zum Live-Test durch das Team: Goi Garg, Cajetan Perwein, Jeet Gupta, Reyan Zein. Fragen der Jury beantworten.</a:t>
             </a:r>
           </a:p>
         </p:txBody>
@@ -4364,7 +4364,7 @@
           <a:p>
             <a:pPr>
               <a:spcAft>
-                <a:spcPts val="2800"/>
+                <a:spcPts val="2000"/>
               </a:spcAft>
               <a:defRPr sz="1600">
                 <a:solidFill>
@@ -4383,7 +4383,23 @@
           </a:p>
           <a:p>
             <a:pPr>
+              <a:spcAft>
+                <a:spcPts val="1600"/>
+              </a:spcAft>
               <a:defRPr sz="1300" b="1">
+                <a:solidFill>
+                  <a:srgbClr val="002D66"/>
+                </a:solidFill>
+                <a:latin typeface="Arial"/>
+              </a:defRPr>
+            </a:pPr>
+            <a:r>
+              <a:t>Team: Goi Garg  ·  Cajetan Perwein  ·  Jeet Gupta  ·  Reyan Zein</a:t>
+            </a:r>
+          </a:p>
+          <a:p>
+            <a:pPr>
+              <a:defRPr sz="1200" b="1">
                 <a:solidFill>
                   <a:srgbClr val="15803D"/>
                 </a:solidFill>
@@ -5522,8 +5538,8 @@
         </p:nvSpPr>
         <p:spPr>
           <a:xfrm>
-            <a:off x="2011680" y="2011680"/>
-            <a:ext cx="8138160" cy="3840480"/>
+            <a:off x="2011680" y="1828800"/>
+            <a:ext cx="8138160" cy="4114800"/>
           </a:xfrm>
           <a:prstGeom prst="roundRect">
             <a:avLst/>
@@ -5567,8 +5583,8 @@
         </p:nvSpPr>
         <p:spPr>
           <a:xfrm>
-            <a:off x="2194560" y="2148840"/>
-            <a:ext cx="7772400" cy="3566160"/>
+            <a:off x="2194560" y="1965960"/>
+            <a:ext cx="7772400" cy="3840480"/>
           </a:xfrm>
           <a:prstGeom prst="rect">
             <a:avLst/>
@@ -5632,7 +5648,12 @@
             </a:r>
             <a:br/>
             <a:r>
-              <a:t>• GitHub Repository: https://github.com/goigarg/competent</a:t>
+              <a:t>• GitHub: https://github.com/goigarg/competent</a:t>
+            </a:r>
+            <a:br/>
+            <a:br/>
+            <a:r>
+              <a:t>Team: Goi Garg · Cajetan Perwein · Jeet Gupta · Reyan Zein</a:t>
             </a:r>
             <a:br/>
             <a:br/>

</xml_diff>

<commit_message>
feat: add 2030 future implementation ideas and roadmap to presentation and docs
</commit_message>
<xml_diff>
--- a/docs/Kompetent-Buergerassistent-2030.pptx
+++ b/docs/Kompetent-Buergerassistent-2030.pptx
@@ -16,6 +16,7 @@
     <p:sldId id="264" r:id="rId16"/>
     <p:sldId id="265" r:id="rId17"/>
     <p:sldId id="266" r:id="rId18"/>
+    <p:sldId id="267" r:id="rId19"/>
   </p:sldIdLst>
   <p:sldSz cx="12191695" cy="6858000" type="screen4x3"/>
   <p:notesSz cx="6858000" cy="9144000"/>
@@ -608,6 +609,76 @@
 </file>
 
 <file path=ppt/notesSlides/notesSlide11.xml><?xml version="1.0" encoding="utf-8"?>
+<p:notes xmlns:a="http://schemas.openxmlformats.org/drawingml/2006/main" xmlns:p="http://schemas.openxmlformats.org/presentationml/2006/main" xmlns:r="http://schemas.openxmlformats.org/officeDocument/2006/relationships">
+  <p:cSld>
+    <p:spTree>
+      <p:nvGrpSpPr>
+        <p:cNvPr id="1" name=""/>
+        <p:cNvGrpSpPr/>
+        <p:nvPr/>
+      </p:nvGrpSpPr>
+      <p:grpSpPr>
+        <a:xfrm>
+          <a:off x="0" y="0"/>
+          <a:ext cx="0" cy="0"/>
+          <a:chOff x="0" y="0"/>
+          <a:chExt cx="0" cy="0"/>
+        </a:xfrm>
+      </p:grpSpPr>
+      <p:sp>
+        <p:nvSpPr>
+          <p:cNvPr id="2" name="Slide Image Placeholder 1"/>
+          <p:cNvSpPr>
+            <a:spLocks noGrp="1"/>
+          </p:cNvSpPr>
+          <p:nvPr>
+            <p:ph type="sldImg" idx="2"/>
+          </p:nvPr>
+        </p:nvSpPr>
+        <p:spPr/>
+      </p:sp>
+      <p:sp>
+        <p:nvSpPr>
+          <p:cNvPr id="3" name="Notes Placeholder 2"/>
+          <p:cNvSpPr>
+            <a:spLocks noGrp="1"/>
+          </p:cNvSpPr>
+          <p:nvPr>
+            <p:ph type="body" idx="3" sz="quarter"/>
+          </p:nvPr>
+        </p:nvSpPr>
+        <p:spPr/>
+        <p:txBody>
+          <a:bodyPr/>
+          <a:lstStyle/>
+          <a:p>
+            <a:r>
+              <a:t>Roadmap 2030: WhatsApp/Telegram-Zugang, automatisches Ausfüllen und Einreichen von Anträgen (Meldezettel), ID Austria Signatur, proaktive Lebenslagen-Trigger, Voice-Kioske und KI-Copilot für Beamte.</a:t>
+            </a:r>
+          </a:p>
+        </p:txBody>
+      </p:sp>
+      <p:sp>
+        <p:nvSpPr>
+          <p:cNvPr id="4" name="Slide Number Placeholder 3"/>
+          <p:cNvSpPr>
+            <a:spLocks noGrp="1"/>
+          </p:cNvSpPr>
+          <p:nvPr>
+            <p:ph type="sldNum" idx="5" sz="quarter"/>
+          </p:nvPr>
+        </p:nvSpPr>
+        <p:spPr/>
+      </p:sp>
+    </p:spTree>
+  </p:cSld>
+  <p:clrMapOvr>
+    <a:masterClrMapping/>
+  </p:clrMapOvr>
+</p:notes>
+</file>
+
+<file path=ppt/notesSlides/notesSlide12.xml><?xml version="1.0" encoding="utf-8"?>
 <p:notes xmlns:a="http://schemas.openxmlformats.org/drawingml/2006/main" xmlns:p="http://schemas.openxmlformats.org/presentationml/2006/main" xmlns:r="http://schemas.openxmlformats.org/officeDocument/2006/relationships">
   <p:cSld>
     <p:spTree>
@@ -5145,6 +5216,1060 @@
 </file>
 
 <file path=ppt/slides/slide11.xml><?xml version="1.0" encoding="utf-8"?>
+<p:sld xmlns:a="http://schemas.openxmlformats.org/drawingml/2006/main" xmlns:p="http://schemas.openxmlformats.org/presentationml/2006/main" xmlns:r="http://schemas.openxmlformats.org/officeDocument/2006/relationships">
+  <p:cSld>
+    <p:spTree>
+      <p:nvGrpSpPr>
+        <p:cNvPr id="1" name=""/>
+        <p:cNvGrpSpPr/>
+        <p:nvPr/>
+      </p:nvGrpSpPr>
+      <p:grpSpPr/>
+      <p:sp>
+        <p:nvSpPr>
+          <p:cNvPr id="2" name="Rectangle 1"/>
+          <p:cNvSpPr/>
+          <p:nvPr/>
+        </p:nvSpPr>
+        <p:spPr>
+          <a:xfrm>
+            <a:off x="0" y="0"/>
+            <a:ext cx="12191695" cy="6858000"/>
+          </a:xfrm>
+          <a:prstGeom prst="rect">
+            <a:avLst/>
+          </a:prstGeom>
+          <a:solidFill>
+            <a:srgbClr val="FFFFFF"/>
+          </a:solidFill>
+          <a:ln>
+            <a:solidFill>
+              <a:srgbClr val="FFFFFF"/>
+            </a:solidFill>
+          </a:ln>
+        </p:spPr>
+        <p:style>
+          <a:lnRef idx="1">
+            <a:schemeClr val="accent1"/>
+          </a:lnRef>
+          <a:fillRef idx="3">
+            <a:schemeClr val="accent1"/>
+          </a:fillRef>
+          <a:effectRef idx="2">
+            <a:schemeClr val="accent1"/>
+          </a:effectRef>
+          <a:fontRef idx="minor">
+            <a:schemeClr val="lt1"/>
+          </a:fontRef>
+        </p:style>
+        <p:txBody>
+          <a:bodyPr rtlCol="0" anchor="ctr"/>
+          <a:lstStyle/>
+          <a:p>
+            <a:pPr algn="ctr"/>
+          </a:p>
+        </p:txBody>
+      </p:sp>
+      <p:sp>
+        <p:nvSpPr>
+          <p:cNvPr id="3" name="Rectangle 2"/>
+          <p:cNvSpPr/>
+          <p:nvPr/>
+        </p:nvSpPr>
+        <p:spPr>
+          <a:xfrm>
+            <a:off x="0" y="0"/>
+            <a:ext cx="12191695" cy="777240"/>
+          </a:xfrm>
+          <a:prstGeom prst="rect">
+            <a:avLst/>
+          </a:prstGeom>
+          <a:solidFill>
+            <a:srgbClr val="FFFFFF"/>
+          </a:solidFill>
+          <a:ln>
+            <a:solidFill>
+              <a:srgbClr val="E2E8F0"/>
+            </a:solidFill>
+          </a:ln>
+        </p:spPr>
+        <p:style>
+          <a:lnRef idx="1">
+            <a:schemeClr val="accent1"/>
+          </a:lnRef>
+          <a:fillRef idx="3">
+            <a:schemeClr val="accent1"/>
+          </a:fillRef>
+          <a:effectRef idx="2">
+            <a:schemeClr val="accent1"/>
+          </a:effectRef>
+          <a:fontRef idx="minor">
+            <a:schemeClr val="lt1"/>
+          </a:fontRef>
+        </p:style>
+        <p:txBody>
+          <a:bodyPr rtlCol="0" anchor="ctr"/>
+          <a:lstStyle/>
+          <a:p>
+            <a:pPr algn="ctr"/>
+          </a:p>
+        </p:txBody>
+      </p:sp>
+      <p:sp>
+        <p:nvSpPr>
+          <p:cNvPr id="4" name="Rectangle 3"/>
+          <p:cNvSpPr/>
+          <p:nvPr/>
+        </p:nvSpPr>
+        <p:spPr>
+          <a:xfrm>
+            <a:off x="548640" y="201168"/>
+            <a:ext cx="320040" cy="109728"/>
+          </a:xfrm>
+          <a:prstGeom prst="rect">
+            <a:avLst/>
+          </a:prstGeom>
+          <a:solidFill>
+            <a:srgbClr val="E1320F"/>
+          </a:solidFill>
+          <a:ln>
+            <a:solidFill>
+              <a:srgbClr val="E1320F"/>
+            </a:solidFill>
+          </a:ln>
+        </p:spPr>
+        <p:style>
+          <a:lnRef idx="1">
+            <a:schemeClr val="accent1"/>
+          </a:lnRef>
+          <a:fillRef idx="3">
+            <a:schemeClr val="accent1"/>
+          </a:fillRef>
+          <a:effectRef idx="2">
+            <a:schemeClr val="accent1"/>
+          </a:effectRef>
+          <a:fontRef idx="minor">
+            <a:schemeClr val="lt1"/>
+          </a:fontRef>
+        </p:style>
+        <p:txBody>
+          <a:bodyPr rtlCol="0" anchor="ctr"/>
+          <a:lstStyle/>
+          <a:p>
+            <a:pPr algn="ctr"/>
+          </a:p>
+        </p:txBody>
+      </p:sp>
+      <p:sp>
+        <p:nvSpPr>
+          <p:cNvPr id="5" name="Rectangle 4"/>
+          <p:cNvSpPr/>
+          <p:nvPr/>
+        </p:nvSpPr>
+        <p:spPr>
+          <a:xfrm>
+            <a:off x="548640" y="310896"/>
+            <a:ext cx="320040" cy="109728"/>
+          </a:xfrm>
+          <a:prstGeom prst="rect">
+            <a:avLst/>
+          </a:prstGeom>
+          <a:solidFill>
+            <a:srgbClr val="FFFFFF"/>
+          </a:solidFill>
+          <a:ln>
+            <a:solidFill>
+              <a:srgbClr val="E2E8F0"/>
+            </a:solidFill>
+          </a:ln>
+        </p:spPr>
+        <p:style>
+          <a:lnRef idx="1">
+            <a:schemeClr val="accent1"/>
+          </a:lnRef>
+          <a:fillRef idx="3">
+            <a:schemeClr val="accent1"/>
+          </a:fillRef>
+          <a:effectRef idx="2">
+            <a:schemeClr val="accent1"/>
+          </a:effectRef>
+          <a:fontRef idx="minor">
+            <a:schemeClr val="lt1"/>
+          </a:fontRef>
+        </p:style>
+        <p:txBody>
+          <a:bodyPr rtlCol="0" anchor="ctr"/>
+          <a:lstStyle/>
+          <a:p>
+            <a:pPr algn="ctr"/>
+          </a:p>
+        </p:txBody>
+      </p:sp>
+      <p:sp>
+        <p:nvSpPr>
+          <p:cNvPr id="6" name="Rectangle 5"/>
+          <p:cNvSpPr/>
+          <p:nvPr/>
+        </p:nvSpPr>
+        <p:spPr>
+          <a:xfrm>
+            <a:off x="548640" y="420624"/>
+            <a:ext cx="320040" cy="109728"/>
+          </a:xfrm>
+          <a:prstGeom prst="rect">
+            <a:avLst/>
+          </a:prstGeom>
+          <a:solidFill>
+            <a:srgbClr val="E1320F"/>
+          </a:solidFill>
+          <a:ln>
+            <a:solidFill>
+              <a:srgbClr val="E1320F"/>
+            </a:solidFill>
+          </a:ln>
+        </p:spPr>
+        <p:style>
+          <a:lnRef idx="1">
+            <a:schemeClr val="accent1"/>
+          </a:lnRef>
+          <a:fillRef idx="3">
+            <a:schemeClr val="accent1"/>
+          </a:fillRef>
+          <a:effectRef idx="2">
+            <a:schemeClr val="accent1"/>
+          </a:effectRef>
+          <a:fontRef idx="minor">
+            <a:schemeClr val="lt1"/>
+          </a:fontRef>
+        </p:style>
+        <p:txBody>
+          <a:bodyPr rtlCol="0" anchor="ctr"/>
+          <a:lstStyle/>
+          <a:p>
+            <a:pPr algn="ctr"/>
+          </a:p>
+        </p:txBody>
+      </p:sp>
+      <p:sp>
+        <p:nvSpPr>
+          <p:cNvPr id="7" name="TextBox 6"/>
+          <p:cNvSpPr txBox="1"/>
+          <p:nvPr/>
+        </p:nvSpPr>
+        <p:spPr>
+          <a:xfrm>
+            <a:off x="1005840" y="146304"/>
+            <a:ext cx="5486400" cy="457200"/>
+          </a:xfrm>
+          <a:prstGeom prst="rect">
+            <a:avLst/>
+          </a:prstGeom>
+          <a:noFill/>
+        </p:spPr>
+        <p:txBody>
+          <a:bodyPr wrap="square">
+            <a:spAutoFit/>
+          </a:bodyPr>
+          <a:lstStyle/>
+          <a:p>
+            <a:pPr>
+              <a:defRPr sz="1600" b="1">
+                <a:solidFill>
+                  <a:srgbClr val="002D66"/>
+                </a:solidFill>
+                <a:latin typeface="Arial"/>
+              </a:defRPr>
+            </a:pPr>
+            <a:r>
+              <a:t>Kompetent</a:t>
+            </a:r>
+            <a:r>
+              <a:rPr sz="1400" b="0">
+                <a:solidFill>
+                  <a:srgbClr val="64748B"/>
+                </a:solidFill>
+              </a:rPr>
+              <a:t>  ·  Digitaler Bürgerassistent 2030</a:t>
+            </a:r>
+          </a:p>
+        </p:txBody>
+      </p:sp>
+      <p:sp>
+        <p:nvSpPr>
+          <p:cNvPr id="8" name="TextBox 7"/>
+          <p:cNvSpPr txBox="1"/>
+          <p:nvPr/>
+        </p:nvSpPr>
+        <p:spPr>
+          <a:xfrm>
+            <a:off x="6583680" y="164592"/>
+            <a:ext cx="5029200" cy="457200"/>
+          </a:xfrm>
+          <a:prstGeom prst="rect">
+            <a:avLst/>
+          </a:prstGeom>
+          <a:noFill/>
+        </p:spPr>
+        <p:txBody>
+          <a:bodyPr wrap="none">
+            <a:spAutoFit/>
+          </a:bodyPr>
+          <a:lstStyle/>
+          <a:p>
+            <a:pPr algn="r">
+              <a:defRPr sz="1000" b="1">
+                <a:solidFill>
+                  <a:srgbClr val="64748B"/>
+                </a:solidFill>
+                <a:latin typeface="Arial"/>
+              </a:defRPr>
+            </a:pPr>
+            <a:r>
+              <a:t>DIGITALE ASSISTENTEN: EVOLUTION BIS 2030 (ÖFFENTLICHER SEKTOR)</a:t>
+            </a:r>
+          </a:p>
+        </p:txBody>
+      </p:sp>
+      <p:sp>
+        <p:nvSpPr>
+          <p:cNvPr id="9" name="TextBox 8"/>
+          <p:cNvSpPr txBox="1"/>
+          <p:nvPr/>
+        </p:nvSpPr>
+        <p:spPr>
+          <a:xfrm>
+            <a:off x="548640" y="960120"/>
+            <a:ext cx="11094415" cy="731520"/>
+          </a:xfrm>
+          <a:prstGeom prst="rect">
+            <a:avLst/>
+          </a:prstGeom>
+          <a:noFill/>
+        </p:spPr>
+        <p:txBody>
+          <a:bodyPr wrap="square">
+            <a:spAutoFit/>
+          </a:bodyPr>
+          <a:lstStyle/>
+          <a:p>
+            <a:pPr>
+              <a:defRPr sz="2400" b="1">
+                <a:solidFill>
+                  <a:srgbClr val="002D66"/>
+                </a:solidFill>
+                <a:latin typeface="Arial"/>
+              </a:defRPr>
+            </a:pPr>
+            <a:r>
+              <a:t>Ausblick &amp; Roadmap: Evolution bis 2030</a:t>
+            </a:r>
+          </a:p>
+        </p:txBody>
+      </p:sp>
+      <p:sp>
+        <p:nvSpPr>
+          <p:cNvPr id="10" name="TextBox 9"/>
+          <p:cNvSpPr txBox="1"/>
+          <p:nvPr/>
+        </p:nvSpPr>
+        <p:spPr>
+          <a:xfrm>
+            <a:off x="548640" y="6400800"/>
+            <a:ext cx="11094415" cy="365760"/>
+          </a:xfrm>
+          <a:prstGeom prst="rect">
+            <a:avLst/>
+          </a:prstGeom>
+          <a:noFill/>
+        </p:spPr>
+        <p:txBody>
+          <a:bodyPr wrap="none">
+            <a:spAutoFit/>
+          </a:bodyPr>
+          <a:lstStyle/>
+          <a:p>
+            <a:pPr>
+              <a:defRPr sz="1000">
+                <a:solidFill>
+                  <a:srgbClr val="64748B"/>
+                </a:solidFill>
+              </a:defRPr>
+            </a:pPr>
+            <a:r>
+              <a:t>Live Prototype: competent.shiv.ovh   |   Caseworker Portal: competent.shiv.ovh/portal</a:t>
+            </a:r>
+          </a:p>
+        </p:txBody>
+      </p:sp>
+      <p:sp>
+        <p:nvSpPr>
+          <p:cNvPr id="11" name="Rounded Rectangle 10"/>
+          <p:cNvSpPr/>
+          <p:nvPr/>
+        </p:nvSpPr>
+        <p:spPr>
+          <a:xfrm>
+            <a:off x="548640" y="1828800"/>
+            <a:ext cx="3474720" cy="2103120"/>
+          </a:xfrm>
+          <a:prstGeom prst="roundRect">
+            <a:avLst/>
+          </a:prstGeom>
+          <a:solidFill>
+            <a:srgbClr val="FFFFFF"/>
+          </a:solidFill>
+          <a:ln w="25400">
+            <a:solidFill>
+              <a:srgbClr val="002D66"/>
+            </a:solidFill>
+          </a:ln>
+        </p:spPr>
+        <p:style>
+          <a:lnRef idx="1">
+            <a:schemeClr val="accent1"/>
+          </a:lnRef>
+          <a:fillRef idx="3">
+            <a:schemeClr val="accent1"/>
+          </a:fillRef>
+          <a:effectRef idx="2">
+            <a:schemeClr val="accent1"/>
+          </a:effectRef>
+          <a:fontRef idx="minor">
+            <a:schemeClr val="lt1"/>
+          </a:fontRef>
+        </p:style>
+        <p:txBody>
+          <a:bodyPr rtlCol="0" anchor="ctr"/>
+          <a:lstStyle/>
+          <a:p>
+            <a:pPr algn="ctr"/>
+          </a:p>
+        </p:txBody>
+      </p:sp>
+      <p:sp>
+        <p:nvSpPr>
+          <p:cNvPr id="12" name="TextBox 11"/>
+          <p:cNvSpPr txBox="1"/>
+          <p:nvPr/>
+        </p:nvSpPr>
+        <p:spPr>
+          <a:xfrm>
+            <a:off x="731520" y="1965960"/>
+            <a:ext cx="3108960" cy="1828800"/>
+          </a:xfrm>
+          <a:prstGeom prst="rect">
+            <a:avLst/>
+          </a:prstGeom>
+          <a:noFill/>
+        </p:spPr>
+        <p:txBody>
+          <a:bodyPr wrap="square">
+            <a:spAutoFit/>
+          </a:bodyPr>
+          <a:lstStyle/>
+          <a:p>
+            <a:pPr>
+              <a:defRPr sz="900" b="1">
+                <a:solidFill>
+                  <a:srgbClr val="B92B06"/>
+                </a:solidFill>
+                <a:latin typeface="Arial"/>
+              </a:defRPr>
+            </a:pPr>
+            <a:r>
+              <a:t>OMNICHANNEL APIS</a:t>
+            </a:r>
+          </a:p>
+          <a:p>
+            <a:pPr>
+              <a:spcAft>
+                <a:spcPts val="600"/>
+              </a:spcAft>
+              <a:defRPr sz="1400" b="1">
+                <a:solidFill>
+                  <a:srgbClr val="002D66"/>
+                </a:solidFill>
+                <a:latin typeface="Arial"/>
+              </a:defRPr>
+            </a:pPr>
+            <a:r>
+              <a:t>WhatsApp, Telegram &amp; Signal</a:t>
+            </a:r>
+          </a:p>
+          <a:p>
+            <a:pPr>
+              <a:defRPr sz="1100">
+                <a:solidFill>
+                  <a:srgbClr val="0F172A"/>
+                </a:solidFill>
+                <a:latin typeface="Arial"/>
+              </a:defRPr>
+            </a:pPr>
+            <a:r>
+              <a:t>Bürger chatten direkt in ihren gewohnten Messaging-Apps – ohne App-Zwang oder Portal-Logins. Vollständige Verschlüsselung &amp; Datenschutz.</a:t>
+            </a:r>
+          </a:p>
+        </p:txBody>
+      </p:sp>
+      <p:sp>
+        <p:nvSpPr>
+          <p:cNvPr id="13" name="Rounded Rectangle 12"/>
+          <p:cNvSpPr/>
+          <p:nvPr/>
+        </p:nvSpPr>
+        <p:spPr>
+          <a:xfrm>
+            <a:off x="4297680" y="1828800"/>
+            <a:ext cx="3474720" cy="2103120"/>
+          </a:xfrm>
+          <a:prstGeom prst="roundRect">
+            <a:avLst/>
+          </a:prstGeom>
+          <a:solidFill>
+            <a:srgbClr val="FFFFFF"/>
+          </a:solidFill>
+          <a:ln w="25400">
+            <a:solidFill>
+              <a:srgbClr val="002D66"/>
+            </a:solidFill>
+          </a:ln>
+        </p:spPr>
+        <p:style>
+          <a:lnRef idx="1">
+            <a:schemeClr val="accent1"/>
+          </a:lnRef>
+          <a:fillRef idx="3">
+            <a:schemeClr val="accent1"/>
+          </a:fillRef>
+          <a:effectRef idx="2">
+            <a:schemeClr val="accent1"/>
+          </a:effectRef>
+          <a:fontRef idx="minor">
+            <a:schemeClr val="lt1"/>
+          </a:fontRef>
+        </p:style>
+        <p:txBody>
+          <a:bodyPr rtlCol="0" anchor="ctr"/>
+          <a:lstStyle/>
+          <a:p>
+            <a:pPr algn="ctr"/>
+          </a:p>
+        </p:txBody>
+      </p:sp>
+      <p:sp>
+        <p:nvSpPr>
+          <p:cNvPr id="14" name="TextBox 13"/>
+          <p:cNvSpPr txBox="1"/>
+          <p:nvPr/>
+        </p:nvSpPr>
+        <p:spPr>
+          <a:xfrm>
+            <a:off x="4480560" y="1965960"/>
+            <a:ext cx="3108960" cy="1828800"/>
+          </a:xfrm>
+          <a:prstGeom prst="rect">
+            <a:avLst/>
+          </a:prstGeom>
+          <a:noFill/>
+        </p:spPr>
+        <p:txBody>
+          <a:bodyPr wrap="square">
+            <a:spAutoFit/>
+          </a:bodyPr>
+          <a:lstStyle/>
+          <a:p>
+            <a:pPr>
+              <a:defRPr sz="900" b="1">
+                <a:solidFill>
+                  <a:srgbClr val="B92B06"/>
+                </a:solidFill>
+                <a:latin typeface="Arial"/>
+              </a:defRPr>
+            </a:pPr>
+            <a:r>
+              <a:t>END-TO-END AUTOMATISIERUNG</a:t>
+            </a:r>
+          </a:p>
+          <a:p>
+            <a:pPr>
+              <a:spcAft>
+                <a:spcPts val="600"/>
+              </a:spcAft>
+              <a:defRPr sz="1400" b="1">
+                <a:solidFill>
+                  <a:srgbClr val="002D66"/>
+                </a:solidFill>
+                <a:latin typeface="Arial"/>
+              </a:defRPr>
+            </a:pPr>
+            <a:r>
+              <a:t>Autonome Antragsbefüllung</a:t>
+            </a:r>
+          </a:p>
+          <a:p>
+            <a:pPr>
+              <a:defRPr sz="1100">
+                <a:solidFill>
+                  <a:srgbClr val="0F172A"/>
+                </a:solidFill>
+                <a:latin typeface="Arial"/>
+              </a:defRPr>
+            </a:pPr>
+            <a:r>
+              <a:t>Füllt Meldezettel &amp; RWR-Anträge im Dialog aus und reicht sie direkt bei BMI &amp; ZMR ein. Erspart Bürgern PDF-Frust und Beamten Abtipparbeit.</a:t>
+            </a:r>
+          </a:p>
+        </p:txBody>
+      </p:sp>
+      <p:sp>
+        <p:nvSpPr>
+          <p:cNvPr id="15" name="Rounded Rectangle 14"/>
+          <p:cNvSpPr/>
+          <p:nvPr/>
+        </p:nvSpPr>
+        <p:spPr>
+          <a:xfrm>
+            <a:off x="8046720" y="1828800"/>
+            <a:ext cx="3474720" cy="2103120"/>
+          </a:xfrm>
+          <a:prstGeom prst="roundRect">
+            <a:avLst/>
+          </a:prstGeom>
+          <a:solidFill>
+            <a:srgbClr val="FFFFFF"/>
+          </a:solidFill>
+          <a:ln w="25400">
+            <a:solidFill>
+              <a:srgbClr val="002D66"/>
+            </a:solidFill>
+          </a:ln>
+        </p:spPr>
+        <p:style>
+          <a:lnRef idx="1">
+            <a:schemeClr val="accent1"/>
+          </a:lnRef>
+          <a:fillRef idx="3">
+            <a:schemeClr val="accent1"/>
+          </a:fillRef>
+          <a:effectRef idx="2">
+            <a:schemeClr val="accent1"/>
+          </a:effectRef>
+          <a:fontRef idx="minor">
+            <a:schemeClr val="lt1"/>
+          </a:fontRef>
+        </p:style>
+        <p:txBody>
+          <a:bodyPr rtlCol="0" anchor="ctr"/>
+          <a:lstStyle/>
+          <a:p>
+            <a:pPr algn="ctr"/>
+          </a:p>
+        </p:txBody>
+      </p:sp>
+      <p:sp>
+        <p:nvSpPr>
+          <p:cNvPr id="16" name="TextBox 15"/>
+          <p:cNvSpPr txBox="1"/>
+          <p:nvPr/>
+        </p:nvSpPr>
+        <p:spPr>
+          <a:xfrm>
+            <a:off x="8229600" y="1965960"/>
+            <a:ext cx="3108960" cy="1828800"/>
+          </a:xfrm>
+          <a:prstGeom prst="rect">
+            <a:avLst/>
+          </a:prstGeom>
+          <a:noFill/>
+        </p:spPr>
+        <p:txBody>
+          <a:bodyPr wrap="square">
+            <a:spAutoFit/>
+          </a:bodyPr>
+          <a:lstStyle/>
+          <a:p>
+            <a:pPr>
+              <a:defRPr sz="900" b="1">
+                <a:solidFill>
+                  <a:srgbClr val="B92B06"/>
+                </a:solidFill>
+                <a:latin typeface="Arial"/>
+              </a:defRPr>
+            </a:pPr>
+            <a:r>
+              <a:t>DIGITALE SOUVERÄNITÄT</a:t>
+            </a:r>
+          </a:p>
+          <a:p>
+            <a:pPr>
+              <a:spcAft>
+                <a:spcPts val="600"/>
+              </a:spcAft>
+              <a:defRPr sz="1400" b="1">
+                <a:solidFill>
+                  <a:srgbClr val="002D66"/>
+                </a:solidFill>
+                <a:latin typeface="Arial"/>
+              </a:defRPr>
+            </a:pPr>
+            <a:r>
+              <a:t>ID Austria &amp; EUDI-Wallet</a:t>
+            </a:r>
+          </a:p>
+          <a:p>
+            <a:pPr>
+              <a:defRPr sz="1100">
+                <a:solidFill>
+                  <a:srgbClr val="0F172A"/>
+                </a:solidFill>
+                <a:latin typeface="Arial"/>
+              </a:defRPr>
+            </a:pPr>
+            <a:r>
+              <a:t>1-Klick rechtssichere digitale Signatur und Zero-Knowledge-Proofs (z.B. Wohnsitz nachweisen ohne Offenlegung aller Privatdaten).</a:t>
+            </a:r>
+          </a:p>
+        </p:txBody>
+      </p:sp>
+      <p:sp>
+        <p:nvSpPr>
+          <p:cNvPr id="17" name="Rounded Rectangle 16"/>
+          <p:cNvSpPr/>
+          <p:nvPr/>
+        </p:nvSpPr>
+        <p:spPr>
+          <a:xfrm>
+            <a:off x="548640" y="4114800"/>
+            <a:ext cx="3474720" cy="2103120"/>
+          </a:xfrm>
+          <a:prstGeom prst="roundRect">
+            <a:avLst/>
+          </a:prstGeom>
+          <a:solidFill>
+            <a:srgbClr val="F1F5F9"/>
+          </a:solidFill>
+          <a:ln w="12700">
+            <a:solidFill>
+              <a:srgbClr val="E2E8F0"/>
+            </a:solidFill>
+          </a:ln>
+        </p:spPr>
+        <p:style>
+          <a:lnRef idx="1">
+            <a:schemeClr val="accent1"/>
+          </a:lnRef>
+          <a:fillRef idx="3">
+            <a:schemeClr val="accent1"/>
+          </a:fillRef>
+          <a:effectRef idx="2">
+            <a:schemeClr val="accent1"/>
+          </a:effectRef>
+          <a:fontRef idx="minor">
+            <a:schemeClr val="lt1"/>
+          </a:fontRef>
+        </p:style>
+        <p:txBody>
+          <a:bodyPr rtlCol="0" anchor="ctr"/>
+          <a:lstStyle/>
+          <a:p>
+            <a:pPr algn="ctr"/>
+          </a:p>
+        </p:txBody>
+      </p:sp>
+      <p:sp>
+        <p:nvSpPr>
+          <p:cNvPr id="18" name="TextBox 17"/>
+          <p:cNvSpPr txBox="1"/>
+          <p:nvPr/>
+        </p:nvSpPr>
+        <p:spPr>
+          <a:xfrm>
+            <a:off x="731520" y="4251960"/>
+            <a:ext cx="3108960" cy="1828800"/>
+          </a:xfrm>
+          <a:prstGeom prst="rect">
+            <a:avLst/>
+          </a:prstGeom>
+          <a:noFill/>
+        </p:spPr>
+        <p:txBody>
+          <a:bodyPr wrap="square">
+            <a:spAutoFit/>
+          </a:bodyPr>
+          <a:lstStyle/>
+          <a:p>
+            <a:pPr>
+              <a:defRPr sz="900" b="1">
+                <a:solidFill>
+                  <a:srgbClr val="B92B06"/>
+                </a:solidFill>
+                <a:latin typeface="Arial"/>
+              </a:defRPr>
+            </a:pPr>
+            <a:r>
+              <a:t>LEBENSLAGEN-PRINZIP</a:t>
+            </a:r>
+          </a:p>
+          <a:p>
+            <a:pPr>
+              <a:spcAft>
+                <a:spcPts val="600"/>
+              </a:spcAft>
+              <a:defRPr sz="1400" b="1">
+                <a:solidFill>
+                  <a:srgbClr val="002D66"/>
+                </a:solidFill>
+                <a:latin typeface="Arial"/>
+              </a:defRPr>
+            </a:pPr>
+            <a:r>
+              <a:t>Proaktiver Bürger-Staat</a:t>
+            </a:r>
+          </a:p>
+          <a:p>
+            <a:pPr>
+              <a:defRPr sz="1100">
+                <a:solidFill>
+                  <a:srgbClr val="0F172A"/>
+                </a:solidFill>
+                <a:latin typeface="Arial"/>
+              </a:defRPr>
+            </a:pPr>
+            <a:r>
+              <a:t>Erkennt Lebensereignisse voraus: Geburt eines Kindes triggert automatisch Familienbeihilfe; Reisepass warnt 6 Monate vor Ablauf mit 1-Klick Termin.</a:t>
+            </a:r>
+          </a:p>
+        </p:txBody>
+      </p:sp>
+      <p:sp>
+        <p:nvSpPr>
+          <p:cNvPr id="19" name="Rounded Rectangle 18"/>
+          <p:cNvSpPr/>
+          <p:nvPr/>
+        </p:nvSpPr>
+        <p:spPr>
+          <a:xfrm>
+            <a:off x="4297680" y="4114800"/>
+            <a:ext cx="3474720" cy="2103120"/>
+          </a:xfrm>
+          <a:prstGeom prst="roundRect">
+            <a:avLst/>
+          </a:prstGeom>
+          <a:solidFill>
+            <a:srgbClr val="F1F5F9"/>
+          </a:solidFill>
+          <a:ln w="12700">
+            <a:solidFill>
+              <a:srgbClr val="E2E8F0"/>
+            </a:solidFill>
+          </a:ln>
+        </p:spPr>
+        <p:style>
+          <a:lnRef idx="1">
+            <a:schemeClr val="accent1"/>
+          </a:lnRef>
+          <a:fillRef idx="3">
+            <a:schemeClr val="accent1"/>
+          </a:fillRef>
+          <a:effectRef idx="2">
+            <a:schemeClr val="accent1"/>
+          </a:effectRef>
+          <a:fontRef idx="minor">
+            <a:schemeClr val="lt1"/>
+          </a:fontRef>
+        </p:style>
+        <p:txBody>
+          <a:bodyPr rtlCol="0" anchor="ctr"/>
+          <a:lstStyle/>
+          <a:p>
+            <a:pPr algn="ctr"/>
+          </a:p>
+        </p:txBody>
+      </p:sp>
+      <p:sp>
+        <p:nvSpPr>
+          <p:cNvPr id="20" name="TextBox 19"/>
+          <p:cNvSpPr txBox="1"/>
+          <p:nvPr/>
+        </p:nvSpPr>
+        <p:spPr>
+          <a:xfrm>
+            <a:off x="4480560" y="4251960"/>
+            <a:ext cx="3108960" cy="1828800"/>
+          </a:xfrm>
+          <a:prstGeom prst="rect">
+            <a:avLst/>
+          </a:prstGeom>
+          <a:noFill/>
+        </p:spPr>
+        <p:txBody>
+          <a:bodyPr wrap="square">
+            <a:spAutoFit/>
+          </a:bodyPr>
+          <a:lstStyle/>
+          <a:p>
+            <a:pPr>
+              <a:defRPr sz="900" b="1">
+                <a:solidFill>
+                  <a:srgbClr val="B92B06"/>
+                </a:solidFill>
+                <a:latin typeface="Arial"/>
+              </a:defRPr>
+            </a:pPr>
+            <a:r>
+              <a:t>BARRIEREFREIHEIT 2.0</a:t>
+            </a:r>
+          </a:p>
+          <a:p>
+            <a:pPr>
+              <a:spcAft>
+                <a:spcPts val="600"/>
+              </a:spcAft>
+              <a:defRPr sz="1400" b="1">
+                <a:solidFill>
+                  <a:srgbClr val="002D66"/>
+                </a:solidFill>
+                <a:latin typeface="Arial"/>
+              </a:defRPr>
+            </a:pPr>
+            <a:r>
+              <a:t>Voice-First &amp; Amts-Kioske</a:t>
+            </a:r>
+          </a:p>
+          <a:p>
+            <a:pPr>
+              <a:defRPr sz="1100">
+                <a:solidFill>
+                  <a:srgbClr val="0F172A"/>
+                </a:solidFill>
+                <a:latin typeface="Arial"/>
+              </a:defRPr>
+            </a:pPr>
+            <a:r>
+              <a:t>Natürliche Sprachsteuerung in österreichischen Dialekten für Senioren sowie barrierefreie Touch/Voice-Terminals in Ämtern und Postfilialen.</a:t>
+            </a:r>
+          </a:p>
+        </p:txBody>
+      </p:sp>
+      <p:sp>
+        <p:nvSpPr>
+          <p:cNvPr id="21" name="Rounded Rectangle 20"/>
+          <p:cNvSpPr/>
+          <p:nvPr/>
+        </p:nvSpPr>
+        <p:spPr>
+          <a:xfrm>
+            <a:off x="8046720" y="4114800"/>
+            <a:ext cx="3474720" cy="2103120"/>
+          </a:xfrm>
+          <a:prstGeom prst="roundRect">
+            <a:avLst/>
+          </a:prstGeom>
+          <a:solidFill>
+            <a:srgbClr val="F1F5F9"/>
+          </a:solidFill>
+          <a:ln w="12700">
+            <a:solidFill>
+              <a:srgbClr val="E2E8F0"/>
+            </a:solidFill>
+          </a:ln>
+        </p:spPr>
+        <p:style>
+          <a:lnRef idx="1">
+            <a:schemeClr val="accent1"/>
+          </a:lnRef>
+          <a:fillRef idx="3">
+            <a:schemeClr val="accent1"/>
+          </a:fillRef>
+          <a:effectRef idx="2">
+            <a:schemeClr val="accent1"/>
+          </a:effectRef>
+          <a:fontRef idx="minor">
+            <a:schemeClr val="lt1"/>
+          </a:fontRef>
+        </p:style>
+        <p:txBody>
+          <a:bodyPr rtlCol="0" anchor="ctr"/>
+          <a:lstStyle/>
+          <a:p>
+            <a:pPr algn="ctr"/>
+          </a:p>
+        </p:txBody>
+      </p:sp>
+      <p:sp>
+        <p:nvSpPr>
+          <p:cNvPr id="22" name="TextBox 21"/>
+          <p:cNvSpPr txBox="1"/>
+          <p:nvPr/>
+        </p:nvSpPr>
+        <p:spPr>
+          <a:xfrm>
+            <a:off x="8229600" y="4251960"/>
+            <a:ext cx="3108960" cy="1828800"/>
+          </a:xfrm>
+          <a:prstGeom prst="rect">
+            <a:avLst/>
+          </a:prstGeom>
+          <a:noFill/>
+        </p:spPr>
+        <p:txBody>
+          <a:bodyPr wrap="square">
+            <a:spAutoFit/>
+          </a:bodyPr>
+          <a:lstStyle/>
+          <a:p>
+            <a:pPr>
+              <a:defRPr sz="900" b="1">
+                <a:solidFill>
+                  <a:srgbClr val="B92B06"/>
+                </a:solidFill>
+                <a:latin typeface="Arial"/>
+              </a:defRPr>
+            </a:pPr>
+            <a:r>
+              <a:t>VERWALTUNGS-EFFIZIENZ</a:t>
+            </a:r>
+          </a:p>
+          <a:p>
+            <a:pPr>
+              <a:spcAft>
+                <a:spcPts val="600"/>
+              </a:spcAft>
+              <a:defRPr sz="1400" b="1">
+                <a:solidFill>
+                  <a:srgbClr val="002D66"/>
+                </a:solidFill>
+                <a:latin typeface="Arial"/>
+              </a:defRPr>
+            </a:pPr>
+            <a:r>
+              <a:t>KI-Sachbearbeiter-Copilot</a:t>
+            </a:r>
+          </a:p>
+          <a:p>
+            <a:pPr>
+              <a:defRPr sz="1100">
+                <a:solidFill>
+                  <a:srgbClr val="0F172A"/>
+                </a:solidFill>
+                <a:latin typeface="Arial"/>
+              </a:defRPr>
+            </a:pPr>
+            <a:r>
+              <a:t>Prüft Anträge sekundenschnell auf Rechtskonformität (§ MeldeG, NAG), validiert Scans per OCR und erstellt Bescheid-Entwürfe zur Freigabe.</a:t>
+            </a:r>
+          </a:p>
+        </p:txBody>
+      </p:sp>
+    </p:spTree>
+  </p:cSld>
+  <p:clrMapOvr>
+    <a:masterClrMapping/>
+  </p:clrMapOvr>
+</p:sld>
+</file>
+
+<file path=ppt/slides/slide12.xml><?xml version="1.0" encoding="utf-8"?>
 <p:sld xmlns:a="http://schemas.openxmlformats.org/drawingml/2006/main" xmlns:p="http://schemas.openxmlformats.org/presentationml/2006/main" xmlns:r="http://schemas.openxmlformats.org/officeDocument/2006/relationships">
   <p:cSld>
     <p:spTree>

</xml_diff>